<commit_message>
update surv/len thru time plots
</commit_message>
<xml_diff>
--- a/results/figures/surv_thru_time.pptx
+++ b/results/figures/surv_thru_time.pptx
@@ -6156,7 +6156,7 @@
           <p:spPr>
             <a:xfrm>
               <a:off x="7996607" y="2353495"/>
-              <a:ext cx="372526" cy="80101"/>
+              <a:ext cx="347563" cy="80101"/>
             </a:xfrm>
             <a:prstGeom prst="rect">
               <a:avLst/>
@@ -6188,7 +6188,7 @@
                   <a:latin typeface="Helvetica"/>
                   <a:cs typeface="Helvetica"/>
                 </a:rPr>
-                <a:t>W1_TX</a:t>
+                <a:t>W1-TX</a:t>
               </a:r>
             </a:p>
           </p:txBody>
@@ -6202,7 +6202,7 @@
           <p:spPr>
             <a:xfrm>
               <a:off x="7996607" y="2572951"/>
-              <a:ext cx="366491" cy="80101"/>
+              <a:ext cx="341528" cy="80101"/>
             </a:xfrm>
             <a:prstGeom prst="rect">
               <a:avLst/>
@@ -6234,7 +6234,7 @@
                   <a:latin typeface="Helvetica"/>
                   <a:cs typeface="Helvetica"/>
                 </a:rPr>
-                <a:t>W2_LA</a:t>
+                <a:t>W2-LA</a:t>
               </a:r>
             </a:p>
           </p:txBody>
@@ -6248,7 +6248,7 @@
           <p:spPr>
             <a:xfrm>
               <a:off x="7996607" y="2792407"/>
-              <a:ext cx="360182" cy="80101"/>
+              <a:ext cx="335219" cy="80101"/>
             </a:xfrm>
             <a:prstGeom prst="rect">
               <a:avLst/>
@@ -6280,7 +6280,7 @@
                   <a:latin typeface="Helvetica"/>
                   <a:cs typeface="Helvetica"/>
                 </a:rPr>
-                <a:t>W3_FL</a:t>
+                <a:t>W3-FL</a:t>
               </a:r>
             </a:p>
           </p:txBody>
@@ -6294,7 +6294,7 @@
           <p:spPr>
             <a:xfrm>
               <a:off x="7996607" y="3011863"/>
-              <a:ext cx="378835" cy="80101"/>
+              <a:ext cx="353872" cy="80101"/>
             </a:xfrm>
             <a:prstGeom prst="rect">
               <a:avLst/>
@@ -6326,7 +6326,7 @@
                   <a:latin typeface="Helvetica"/>
                   <a:cs typeface="Helvetica"/>
                 </a:rPr>
-                <a:t>W4_VA</a:t>
+                <a:t>W4-VA</a:t>
               </a:r>
             </a:p>
           </p:txBody>
@@ -6340,7 +6340,7 @@
           <p:spPr>
             <a:xfrm>
               <a:off x="7996607" y="3231319"/>
-              <a:ext cx="484631" cy="80101"/>
+              <a:ext cx="459668" cy="80101"/>
             </a:xfrm>
             <a:prstGeom prst="rect">
               <a:avLst/>
@@ -6372,7 +6372,7 @@
                   <a:latin typeface="Helvetica"/>
                   <a:cs typeface="Helvetica"/>
                 </a:rPr>
-                <a:t>S1_LOLA</a:t>
+                <a:t>S1-LOLA</a:t>
               </a:r>
             </a:p>
           </p:txBody>
@@ -6386,7 +6386,7 @@
           <p:spPr>
             <a:xfrm>
               <a:off x="7996607" y="3450775"/>
-              <a:ext cx="503102" cy="80101"/>
+              <a:ext cx="478139" cy="80101"/>
             </a:xfrm>
             <a:prstGeom prst="rect">
               <a:avLst/>
@@ -6418,7 +6418,7 @@
                   <a:latin typeface="Helvetica"/>
                   <a:cs typeface="Helvetica"/>
                 </a:rPr>
-                <a:t>S2_DEBY</a:t>
+                <a:t>S2-DEBY</a:t>
               </a:r>
             </a:p>
           </p:txBody>
@@ -6432,7 +6432,7 @@
           <p:spPr>
             <a:xfrm>
               <a:off x="7996607" y="3670231"/>
-              <a:ext cx="391088" cy="80101"/>
+              <a:ext cx="366125" cy="80101"/>
             </a:xfrm>
             <a:prstGeom prst="rect">
               <a:avLst/>
@@ -6464,7 +6464,7 @@
                   <a:latin typeface="Helvetica"/>
                   <a:cs typeface="Helvetica"/>
                 </a:rPr>
-                <a:t>W5_NH</a:t>
+                <a:t>W5-NH</a:t>
               </a:r>
             </a:p>
           </p:txBody>
@@ -6478,7 +6478,7 @@
           <p:spPr>
             <a:xfrm>
               <a:off x="7996607" y="3889687"/>
-              <a:ext cx="397398" cy="80101"/>
+              <a:ext cx="372435" cy="80101"/>
             </a:xfrm>
             <a:prstGeom prst="rect">
               <a:avLst/>
@@ -6510,7 +6510,7 @@
                   <a:latin typeface="Helvetica"/>
                   <a:cs typeface="Helvetica"/>
                 </a:rPr>
-                <a:t>W6_ME</a:t>
+                <a:t>W6-ME</a:t>
               </a:r>
             </a:p>
           </p:txBody>
@@ -6524,7 +6524,7 @@
           <p:spPr>
             <a:xfrm>
               <a:off x="972874" y="1669789"/>
-              <a:ext cx="4079778" cy="182239"/>
+              <a:ext cx="4488972" cy="182239"/>
             </a:xfrm>
             <a:prstGeom prst="rect">
               <a:avLst/>
@@ -6556,7 +6556,7 @@
                   <a:latin typeface="Helvetica"/>
                   <a:cs typeface="Helvetica"/>
                 </a:rPr>
-                <a:t>Lewisetta: Oyster Survival thru Time</a:t>
+                <a:t>(A) Lewisetta: Oyster Survival thru Time</a:t>
               </a:r>
             </a:p>
           </p:txBody>
@@ -10528,7 +10528,7 @@
           <p:spPr>
             <a:xfrm>
               <a:off x="7996607" y="2353495"/>
-              <a:ext cx="372526" cy="80101"/>
+              <a:ext cx="347563" cy="80101"/>
             </a:xfrm>
             <a:prstGeom prst="rect">
               <a:avLst/>
@@ -10560,7 +10560,7 @@
                   <a:latin typeface="Helvetica"/>
                   <a:cs typeface="Helvetica"/>
                 </a:rPr>
-                <a:t>W1_TX</a:t>
+                <a:t>W1-TX</a:t>
               </a:r>
             </a:p>
           </p:txBody>
@@ -10574,7 +10574,7 @@
           <p:spPr>
             <a:xfrm>
               <a:off x="7996607" y="2572951"/>
-              <a:ext cx="366491" cy="80101"/>
+              <a:ext cx="341528" cy="80101"/>
             </a:xfrm>
             <a:prstGeom prst="rect">
               <a:avLst/>
@@ -10606,7 +10606,7 @@
                   <a:latin typeface="Helvetica"/>
                   <a:cs typeface="Helvetica"/>
                 </a:rPr>
-                <a:t>W2_LA</a:t>
+                <a:t>W2-LA</a:t>
               </a:r>
             </a:p>
           </p:txBody>
@@ -10620,7 +10620,7 @@
           <p:spPr>
             <a:xfrm>
               <a:off x="7996607" y="2792407"/>
-              <a:ext cx="360182" cy="80101"/>
+              <a:ext cx="335219" cy="80101"/>
             </a:xfrm>
             <a:prstGeom prst="rect">
               <a:avLst/>
@@ -10652,7 +10652,7 @@
                   <a:latin typeface="Helvetica"/>
                   <a:cs typeface="Helvetica"/>
                 </a:rPr>
-                <a:t>W3_FL</a:t>
+                <a:t>W3-FL</a:t>
               </a:r>
             </a:p>
           </p:txBody>
@@ -10666,7 +10666,7 @@
           <p:spPr>
             <a:xfrm>
               <a:off x="7996607" y="3011863"/>
-              <a:ext cx="378835" cy="80101"/>
+              <a:ext cx="353872" cy="80101"/>
             </a:xfrm>
             <a:prstGeom prst="rect">
               <a:avLst/>
@@ -10698,7 +10698,7 @@
                   <a:latin typeface="Helvetica"/>
                   <a:cs typeface="Helvetica"/>
                 </a:rPr>
-                <a:t>W4_VA</a:t>
+                <a:t>W4-VA</a:t>
               </a:r>
             </a:p>
           </p:txBody>
@@ -10712,7 +10712,7 @@
           <p:spPr>
             <a:xfrm>
               <a:off x="7996607" y="3231319"/>
-              <a:ext cx="484631" cy="80101"/>
+              <a:ext cx="459668" cy="80101"/>
             </a:xfrm>
             <a:prstGeom prst="rect">
               <a:avLst/>
@@ -10744,7 +10744,7 @@
                   <a:latin typeface="Helvetica"/>
                   <a:cs typeface="Helvetica"/>
                 </a:rPr>
-                <a:t>S1_LOLA</a:t>
+                <a:t>S1-LOLA</a:t>
               </a:r>
             </a:p>
           </p:txBody>
@@ -10758,7 +10758,7 @@
           <p:spPr>
             <a:xfrm>
               <a:off x="7996607" y="3450775"/>
-              <a:ext cx="503102" cy="80101"/>
+              <a:ext cx="478139" cy="80101"/>
             </a:xfrm>
             <a:prstGeom prst="rect">
               <a:avLst/>
@@ -10790,7 +10790,7 @@
                   <a:latin typeface="Helvetica"/>
                   <a:cs typeface="Helvetica"/>
                 </a:rPr>
-                <a:t>S2_DEBY</a:t>
+                <a:t>S2-DEBY</a:t>
               </a:r>
             </a:p>
           </p:txBody>
@@ -10804,7 +10804,7 @@
           <p:spPr>
             <a:xfrm>
               <a:off x="7996607" y="3670231"/>
-              <a:ext cx="391088" cy="80101"/>
+              <a:ext cx="366125" cy="80101"/>
             </a:xfrm>
             <a:prstGeom prst="rect">
               <a:avLst/>
@@ -10836,7 +10836,7 @@
                   <a:latin typeface="Helvetica"/>
                   <a:cs typeface="Helvetica"/>
                 </a:rPr>
-                <a:t>W5_NH</a:t>
+                <a:t>W5-NH</a:t>
               </a:r>
             </a:p>
           </p:txBody>
@@ -10850,7 +10850,7 @@
           <p:spPr>
             <a:xfrm>
               <a:off x="7996607" y="3889687"/>
-              <a:ext cx="397398" cy="80101"/>
+              <a:ext cx="372435" cy="80101"/>
             </a:xfrm>
             <a:prstGeom prst="rect">
               <a:avLst/>
@@ -10882,7 +10882,7 @@
                   <a:latin typeface="Helvetica"/>
                   <a:cs typeface="Helvetica"/>
                 </a:rPr>
-                <a:t>W6_ME</a:t>
+                <a:t>W6-ME</a:t>
               </a:r>
             </a:p>
           </p:txBody>
@@ -10896,7 +10896,7 @@
           <p:spPr>
             <a:xfrm>
               <a:off x="972874" y="1669789"/>
-              <a:ext cx="4192249" cy="182239"/>
+              <a:ext cx="4601443" cy="182239"/>
             </a:xfrm>
             <a:prstGeom prst="rect">
               <a:avLst/>
@@ -10928,7 +10928,7 @@
                   <a:latin typeface="Helvetica"/>
                   <a:cs typeface="Helvetica"/>
                 </a:rPr>
-                <a:t>York River: Oyster Survival thru Time</a:t>
+                <a:t>(B) York River: Oyster Survival thru Time</a:t>
               </a:r>
             </a:p>
           </p:txBody>

</xml_diff>